<commit_message>
added some files and updated plots
</commit_message>
<xml_diff>
--- a/figures/Figures.pptx
+++ b/figures/Figures.pptx
@@ -11,6 +11,7 @@
     <p:sldId id="261" r:id="rId5"/>
     <p:sldId id="258" r:id="rId6"/>
     <p:sldId id="259" r:id="rId7"/>
+    <p:sldId id="263" r:id="rId8"/>
   </p:sldIdLst>
   <p:sldSz cx="12192000" cy="9144000"/>
   <p:notesSz cx="6858000" cy="9144000"/>
@@ -117,1090 +118,53 @@
 </p:presentation>
 </file>
 
-<file path=ppt/revisionInfo.xml><?xml version="1.0" encoding="utf-8"?>
-<p1510:revInfo xmlns:a="http://schemas.openxmlformats.org/drawingml/2006/main" xmlns:r="http://schemas.openxmlformats.org/officeDocument/2006/relationships" xmlns:p1510="http://schemas.microsoft.com/office/powerpoint/2015/10/main">
-  <p1510:revLst>
-    <p1510:client id="{845851A7-F1C6-4417-B1A2-7AC72DF2D5EA}" v="130" dt="2026-01-25T02:01:15.206"/>
-  </p1510:revLst>
-</p1510:revInfo>
-</file>
-
 <file path=ppt/changesInfos/changesInfo1.xml><?xml version="1.0" encoding="utf-8"?>
 <pc:chgInfo xmlns:a="http://schemas.openxmlformats.org/drawingml/2006/main" xmlns:r="http://schemas.openxmlformats.org/officeDocument/2006/relationships" xmlns:ac="http://schemas.microsoft.com/office/drawing/2013/main/command" xmlns:pc="http://schemas.microsoft.com/office/powerpoint/2013/main/command">
   <pc:docChgLst>
     <pc:chgData name="Daniel Bauman" userId="b4990c641f0077cd" providerId="LiveId" clId="{6DEDCE68-9D2E-4C8C-9998-BD219A3A306C}"/>
     <pc:docChg chg="undo custSel addSld modSld">
-      <pc:chgData name="Daniel Bauman" userId="b4990c641f0077cd" providerId="LiveId" clId="{6DEDCE68-9D2E-4C8C-9998-BD219A3A306C}" dt="2026-01-25T02:01:15.206" v="374" actId="20577"/>
+      <pc:chgData name="Daniel Bauman" userId="b4990c641f0077cd" providerId="LiveId" clId="{6DEDCE68-9D2E-4C8C-9998-BD219A3A306C}" dt="2026-03-03T05:36:49.728" v="385" actId="931"/>
       <pc:docMkLst>
         <pc:docMk/>
       </pc:docMkLst>
-      <pc:sldChg chg="modSp mod">
-        <pc:chgData name="Daniel Bauman" userId="b4990c641f0077cd" providerId="LiveId" clId="{6DEDCE68-9D2E-4C8C-9998-BD219A3A306C}" dt="2026-01-25T02:01:15.206" v="374" actId="20577"/>
+      <pc:sldChg chg="addSp delSp modSp new mod">
+        <pc:chgData name="Daniel Bauman" userId="b4990c641f0077cd" providerId="LiveId" clId="{6DEDCE68-9D2E-4C8C-9998-BD219A3A306C}" dt="2026-03-03T05:36:49.728" v="385" actId="931"/>
         <pc:sldMkLst>
           <pc:docMk/>
-          <pc:sldMk cId="4184697988" sldId="259"/>
+          <pc:sldMk cId="3365830087" sldId="263"/>
         </pc:sldMkLst>
-        <pc:spChg chg="mod">
-          <ac:chgData name="Daniel Bauman" userId="b4990c641f0077cd" providerId="LiveId" clId="{6DEDCE68-9D2E-4C8C-9998-BD219A3A306C}" dt="2026-01-25T02:01:02.906" v="366" actId="20577"/>
-          <ac:spMkLst>
+        <pc:picChg chg="add del mod">
+          <ac:chgData name="Daniel Bauman" userId="b4990c641f0077cd" providerId="LiveId" clId="{6DEDCE68-9D2E-4C8C-9998-BD219A3A306C}" dt="2026-03-03T05:36:49.728" v="385" actId="931"/>
+          <ac:picMkLst>
             <pc:docMk/>
-            <pc:sldMk cId="4184697988" sldId="259"/>
-            <ac:spMk id="5" creationId="{E4F2E5B9-7CAA-6D1A-5662-42FAE55F75EE}"/>
-          </ac:spMkLst>
-        </pc:spChg>
-        <pc:spChg chg="mod">
-          <ac:chgData name="Daniel Bauman" userId="b4990c641f0077cd" providerId="LiveId" clId="{6DEDCE68-9D2E-4C8C-9998-BD219A3A306C}" dt="2026-01-25T02:01:02.906" v="366" actId="20577"/>
-          <ac:spMkLst>
+            <pc:sldMk cId="3365830087" sldId="263"/>
+            <ac:picMk id="3" creationId="{4B8A6FBF-3397-ABC7-FE8C-5C06F78066DA}"/>
+          </ac:picMkLst>
+        </pc:picChg>
+        <pc:picChg chg="add del mod">
+          <ac:chgData name="Daniel Bauman" userId="b4990c641f0077cd" providerId="LiveId" clId="{6DEDCE68-9D2E-4C8C-9998-BD219A3A306C}" dt="2026-03-03T05:36:49.728" v="385" actId="931"/>
+          <ac:picMkLst>
             <pc:docMk/>
-            <pc:sldMk cId="4184697988" sldId="259"/>
-            <ac:spMk id="6" creationId="{0D2B9634-26F4-E6D1-392D-478A9286917C}"/>
-          </ac:spMkLst>
-        </pc:spChg>
-        <pc:spChg chg="mod">
-          <ac:chgData name="Daniel Bauman" userId="b4990c641f0077cd" providerId="LiveId" clId="{6DEDCE68-9D2E-4C8C-9998-BD219A3A306C}" dt="2026-01-25T02:01:02.906" v="366" actId="20577"/>
-          <ac:spMkLst>
+            <pc:sldMk cId="3365830087" sldId="263"/>
+            <ac:picMk id="5" creationId="{FEDCF395-86DE-3062-59B9-413FA1D6F9E1}"/>
+          </ac:picMkLst>
+        </pc:picChg>
+        <pc:picChg chg="add del mod">
+          <ac:chgData name="Daniel Bauman" userId="b4990c641f0077cd" providerId="LiveId" clId="{6DEDCE68-9D2E-4C8C-9998-BD219A3A306C}" dt="2026-03-03T05:36:49.728" v="385" actId="931"/>
+          <ac:picMkLst>
             <pc:docMk/>
-            <pc:sldMk cId="4184697988" sldId="259"/>
-            <ac:spMk id="7" creationId="{2B085A2B-8C0E-4102-1495-B8A3257073DD}"/>
-          </ac:spMkLst>
-        </pc:spChg>
-        <pc:spChg chg="mod">
-          <ac:chgData name="Daniel Bauman" userId="b4990c641f0077cd" providerId="LiveId" clId="{6DEDCE68-9D2E-4C8C-9998-BD219A3A306C}" dt="2026-01-25T02:01:02.906" v="366" actId="20577"/>
-          <ac:spMkLst>
+            <pc:sldMk cId="3365830087" sldId="263"/>
+            <ac:picMk id="7" creationId="{34E70C03-6112-87C3-AF89-F756ACC34697}"/>
+          </ac:picMkLst>
+        </pc:picChg>
+        <pc:picChg chg="add del mod">
+          <ac:chgData name="Daniel Bauman" userId="b4990c641f0077cd" providerId="LiveId" clId="{6DEDCE68-9D2E-4C8C-9998-BD219A3A306C}" dt="2026-03-03T05:36:49.728" v="385" actId="931"/>
+          <ac:picMkLst>
             <pc:docMk/>
-            <pc:sldMk cId="4184697988" sldId="259"/>
-            <ac:spMk id="8" creationId="{7D0999FA-FD2A-1B9D-903A-4F19A0FBD985}"/>
-          </ac:spMkLst>
-        </pc:spChg>
-        <pc:spChg chg="mod">
-          <ac:chgData name="Daniel Bauman" userId="b4990c641f0077cd" providerId="LiveId" clId="{6DEDCE68-9D2E-4C8C-9998-BD219A3A306C}" dt="2026-01-25T02:01:02.906" v="366" actId="20577"/>
-          <ac:spMkLst>
-            <pc:docMk/>
-            <pc:sldMk cId="4184697988" sldId="259"/>
-            <ac:spMk id="10" creationId="{267AFE90-EC66-2C91-276E-F0AFAADA9666}"/>
-          </ac:spMkLst>
-        </pc:spChg>
-        <pc:spChg chg="mod">
-          <ac:chgData name="Daniel Bauman" userId="b4990c641f0077cd" providerId="LiveId" clId="{6DEDCE68-9D2E-4C8C-9998-BD219A3A306C}" dt="2026-01-25T02:01:15.206" v="374" actId="20577"/>
-          <ac:spMkLst>
-            <pc:docMk/>
-            <pc:sldMk cId="4184697988" sldId="259"/>
-            <ac:spMk id="36" creationId="{51B26E3B-EA35-43C7-9863-6B0102168276}"/>
-          </ac:spMkLst>
-        </pc:spChg>
-        <pc:spChg chg="mod">
-          <ac:chgData name="Daniel Bauman" userId="b4990c641f0077cd" providerId="LiveId" clId="{6DEDCE68-9D2E-4C8C-9998-BD219A3A306C}" dt="2026-01-25T02:01:02.906" v="366" actId="20577"/>
-          <ac:spMkLst>
-            <pc:docMk/>
-            <pc:sldMk cId="4184697988" sldId="259"/>
-            <ac:spMk id="39" creationId="{0556EBC3-D0B4-FCAA-0E74-52FB9838D1FE}"/>
-          </ac:spMkLst>
-        </pc:spChg>
-        <pc:spChg chg="mod">
-          <ac:chgData name="Daniel Bauman" userId="b4990c641f0077cd" providerId="LiveId" clId="{6DEDCE68-9D2E-4C8C-9998-BD219A3A306C}" dt="2026-01-25T02:01:09.975" v="370" actId="20577"/>
-          <ac:spMkLst>
-            <pc:docMk/>
-            <pc:sldMk cId="4184697988" sldId="259"/>
-            <ac:spMk id="40" creationId="{CE2FD0A3-B525-E8A7-0A39-812B1F167652}"/>
-          </ac:spMkLst>
-        </pc:spChg>
-        <pc:spChg chg="mod">
-          <ac:chgData name="Daniel Bauman" userId="b4990c641f0077cd" providerId="LiveId" clId="{6DEDCE68-9D2E-4C8C-9998-BD219A3A306C}" dt="2026-01-25T02:01:02.631" v="364" actId="20577"/>
-          <ac:spMkLst>
-            <pc:docMk/>
-            <pc:sldMk cId="4184697988" sldId="259"/>
-            <ac:spMk id="72" creationId="{CD6A14B6-8B20-F770-8E05-042A66C3653E}"/>
-          </ac:spMkLst>
-        </pc:spChg>
-        <pc:spChg chg="mod">
-          <ac:chgData name="Daniel Bauman" userId="b4990c641f0077cd" providerId="LiveId" clId="{6DEDCE68-9D2E-4C8C-9998-BD219A3A306C}" dt="2026-01-25T02:01:02.906" v="366" actId="20577"/>
-          <ac:spMkLst>
-            <pc:docMk/>
-            <pc:sldMk cId="4184697988" sldId="259"/>
-            <ac:spMk id="74" creationId="{54A940E5-1306-7A7F-A8BB-4C6B7D36526E}"/>
-          </ac:spMkLst>
-        </pc:spChg>
-        <pc:spChg chg="mod">
-          <ac:chgData name="Daniel Bauman" userId="b4990c641f0077cd" providerId="LiveId" clId="{6DEDCE68-9D2E-4C8C-9998-BD219A3A306C}" dt="2026-01-25T02:01:02.906" v="366" actId="20577"/>
-          <ac:spMkLst>
-            <pc:docMk/>
-            <pc:sldMk cId="4184697988" sldId="259"/>
-            <ac:spMk id="75" creationId="{E72D8483-B4B5-CA84-31D0-8BBAF83A4550}"/>
-          </ac:spMkLst>
-        </pc:spChg>
-        <pc:spChg chg="mod">
-          <ac:chgData name="Daniel Bauman" userId="b4990c641f0077cd" providerId="LiveId" clId="{6DEDCE68-9D2E-4C8C-9998-BD219A3A306C}" dt="2026-01-25T02:01:02.906" v="366" actId="20577"/>
-          <ac:spMkLst>
-            <pc:docMk/>
-            <pc:sldMk cId="4184697988" sldId="259"/>
-            <ac:spMk id="79" creationId="{B3D2E14D-3527-4212-7E79-1E2E471484CF}"/>
-          </ac:spMkLst>
-        </pc:spChg>
-      </pc:sldChg>
-      <pc:sldChg chg="addSp delSp modSp add mod">
-        <pc:chgData name="Daniel Bauman" userId="b4990c641f0077cd" providerId="LiveId" clId="{6DEDCE68-9D2E-4C8C-9998-BD219A3A306C}" dt="2026-01-12T23:44:52.868" v="25" actId="1076"/>
-        <pc:sldMkLst>
-          <pc:docMk/>
-          <pc:sldMk cId="715583163" sldId="260"/>
-        </pc:sldMkLst>
-        <pc:spChg chg="mod">
-          <ac:chgData name="Daniel Bauman" userId="b4990c641f0077cd" providerId="LiveId" clId="{6DEDCE68-9D2E-4C8C-9998-BD219A3A306C}" dt="2026-01-12T23:41:28.846" v="2" actId="1076"/>
-          <ac:spMkLst>
-            <pc:docMk/>
-            <pc:sldMk cId="715583163" sldId="260"/>
-            <ac:spMk id="2" creationId="{2F26121A-13F5-F3FC-EC7C-5624B20B17A8}"/>
-          </ac:spMkLst>
-        </pc:spChg>
-        <pc:spChg chg="add mod">
-          <ac:chgData name="Daniel Bauman" userId="b4990c641f0077cd" providerId="LiveId" clId="{6DEDCE68-9D2E-4C8C-9998-BD219A3A306C}" dt="2026-01-12T23:42:05.149" v="9" actId="20577"/>
-          <ac:spMkLst>
-            <pc:docMk/>
-            <pc:sldMk cId="715583163" sldId="260"/>
-            <ac:spMk id="3" creationId="{2BB1CA29-33A4-3620-2B25-B632D247D678}"/>
-          </ac:spMkLst>
-        </pc:spChg>
-        <pc:spChg chg="mod">
-          <ac:chgData name="Daniel Bauman" userId="b4990c641f0077cd" providerId="LiveId" clId="{6DEDCE68-9D2E-4C8C-9998-BD219A3A306C}" dt="2026-01-12T23:43:54.777" v="17" actId="14100"/>
-          <ac:spMkLst>
-            <pc:docMk/>
-            <pc:sldMk cId="715583163" sldId="260"/>
-            <ac:spMk id="7" creationId="{62572A94-2E43-B375-995F-36D80A0CEE3D}"/>
-          </ac:spMkLst>
-        </pc:spChg>
-        <pc:spChg chg="add mod">
-          <ac:chgData name="Daniel Bauman" userId="b4990c641f0077cd" providerId="LiveId" clId="{6DEDCE68-9D2E-4C8C-9998-BD219A3A306C}" dt="2026-01-12T23:44:52.868" v="25" actId="1076"/>
-          <ac:spMkLst>
-            <pc:docMk/>
-            <pc:sldMk cId="715583163" sldId="260"/>
-            <ac:spMk id="13" creationId="{7AA2B855-2056-48DF-9D60-BEE7D8C7926B}"/>
-          </ac:spMkLst>
-        </pc:spChg>
-        <pc:spChg chg="mod">
-          <ac:chgData name="Daniel Bauman" userId="b4990c641f0077cd" providerId="LiveId" clId="{6DEDCE68-9D2E-4C8C-9998-BD219A3A306C}" dt="2026-01-12T23:41:23.086" v="1" actId="165"/>
-          <ac:spMkLst>
-            <pc:docMk/>
-            <pc:sldMk cId="715583163" sldId="260"/>
-            <ac:spMk id="14" creationId="{3A356DFD-3A87-4F91-5BF8-9E9B345C5E20}"/>
-          </ac:spMkLst>
-        </pc:spChg>
-        <pc:spChg chg="mod topLvl">
-          <ac:chgData name="Daniel Bauman" userId="b4990c641f0077cd" providerId="LiveId" clId="{6DEDCE68-9D2E-4C8C-9998-BD219A3A306C}" dt="2026-01-12T23:44:04.012" v="18" actId="165"/>
-          <ac:spMkLst>
-            <pc:docMk/>
-            <pc:sldMk cId="715583163" sldId="260"/>
-            <ac:spMk id="26" creationId="{B9A0EBEB-47B0-7D39-8CA9-27B257903C29}"/>
-          </ac:spMkLst>
-        </pc:spChg>
-        <pc:spChg chg="mod topLvl">
-          <ac:chgData name="Daniel Bauman" userId="b4990c641f0077cd" providerId="LiveId" clId="{6DEDCE68-9D2E-4C8C-9998-BD219A3A306C}" dt="2026-01-12T23:44:31.851" v="21" actId="1076"/>
-          <ac:spMkLst>
-            <pc:docMk/>
-            <pc:sldMk cId="715583163" sldId="260"/>
-            <ac:spMk id="29" creationId="{547BEB6C-EE52-CC9C-D1F3-E3F3FA0642E6}"/>
-          </ac:spMkLst>
-        </pc:spChg>
-        <pc:spChg chg="mod topLvl">
-          <ac:chgData name="Daniel Bauman" userId="b4990c641f0077cd" providerId="LiveId" clId="{6DEDCE68-9D2E-4C8C-9998-BD219A3A306C}" dt="2026-01-12T23:44:38.280" v="23" actId="1076"/>
-          <ac:spMkLst>
-            <pc:docMk/>
-            <pc:sldMk cId="715583163" sldId="260"/>
-            <ac:spMk id="30" creationId="{8DDB0A1D-F023-A82B-436B-D32F9C4BD5CD}"/>
-          </ac:spMkLst>
-        </pc:spChg>
-        <pc:spChg chg="mod topLvl">
-          <ac:chgData name="Daniel Bauman" userId="b4990c641f0077cd" providerId="LiveId" clId="{6DEDCE68-9D2E-4C8C-9998-BD219A3A306C}" dt="2026-01-12T23:44:04.012" v="18" actId="165"/>
-          <ac:spMkLst>
-            <pc:docMk/>
-            <pc:sldMk cId="715583163" sldId="260"/>
-            <ac:spMk id="31" creationId="{4E100D77-514E-1935-0D7D-672B75F2B065}"/>
-          </ac:spMkLst>
-        </pc:spChg>
-        <pc:spChg chg="mod topLvl">
-          <ac:chgData name="Daniel Bauman" userId="b4990c641f0077cd" providerId="LiveId" clId="{6DEDCE68-9D2E-4C8C-9998-BD219A3A306C}" dt="2026-01-12T23:44:14.205" v="19" actId="165"/>
-          <ac:spMkLst>
-            <pc:docMk/>
-            <pc:sldMk cId="715583163" sldId="260"/>
-            <ac:spMk id="35" creationId="{CA2D1237-B5BF-3A0B-D470-B07DB1A5D0E0}"/>
-          </ac:spMkLst>
-        </pc:spChg>
-        <pc:spChg chg="mod topLvl">
-          <ac:chgData name="Daniel Bauman" userId="b4990c641f0077cd" providerId="LiveId" clId="{6DEDCE68-9D2E-4C8C-9998-BD219A3A306C}" dt="2026-01-12T23:44:14.205" v="19" actId="165"/>
-          <ac:spMkLst>
-            <pc:docMk/>
-            <pc:sldMk cId="715583163" sldId="260"/>
-            <ac:spMk id="36" creationId="{A8CD67A0-B1FB-4B3F-8F26-1586B6AC956A}"/>
-          </ac:spMkLst>
-        </pc:spChg>
-        <pc:spChg chg="mod topLvl">
-          <ac:chgData name="Daniel Bauman" userId="b4990c641f0077cd" providerId="LiveId" clId="{6DEDCE68-9D2E-4C8C-9998-BD219A3A306C}" dt="2026-01-12T23:44:14.205" v="19" actId="165"/>
-          <ac:spMkLst>
-            <pc:docMk/>
-            <pc:sldMk cId="715583163" sldId="260"/>
-            <ac:spMk id="37" creationId="{6FFE2F3B-C823-76AC-F2C9-25EDDDC1D8F1}"/>
-          </ac:spMkLst>
-        </pc:spChg>
-        <pc:spChg chg="mod topLvl">
-          <ac:chgData name="Daniel Bauman" userId="b4990c641f0077cd" providerId="LiveId" clId="{6DEDCE68-9D2E-4C8C-9998-BD219A3A306C}" dt="2026-01-12T23:41:32.776" v="3" actId="1076"/>
-          <ac:spMkLst>
-            <pc:docMk/>
-            <pc:sldMk cId="715583163" sldId="260"/>
-            <ac:spMk id="40" creationId="{8A63B8F0-8B51-EFE7-9FE6-1896D70B681A}"/>
-          </ac:spMkLst>
-        </pc:spChg>
-        <pc:spChg chg="mod topLvl">
-          <ac:chgData name="Daniel Bauman" userId="b4990c641f0077cd" providerId="LiveId" clId="{6DEDCE68-9D2E-4C8C-9998-BD219A3A306C}" dt="2026-01-12T23:41:36.519" v="4" actId="1076"/>
-          <ac:spMkLst>
-            <pc:docMk/>
-            <pc:sldMk cId="715583163" sldId="260"/>
-            <ac:spMk id="41" creationId="{E1D776B5-48C5-2B03-7755-CF3C98539935}"/>
-          </ac:spMkLst>
-        </pc:spChg>
-        <pc:spChg chg="mod">
-          <ac:chgData name="Daniel Bauman" userId="b4990c641f0077cd" providerId="LiveId" clId="{6DEDCE68-9D2E-4C8C-9998-BD219A3A306C}" dt="2026-01-12T23:41:41.174" v="5" actId="1076"/>
-          <ac:spMkLst>
-            <pc:docMk/>
-            <pc:sldMk cId="715583163" sldId="260"/>
-            <ac:spMk id="42" creationId="{13423F05-C832-95A2-02BF-481A33B51E09}"/>
-          </ac:spMkLst>
-        </pc:spChg>
-        <pc:spChg chg="mod topLvl">
-          <ac:chgData name="Daniel Bauman" userId="b4990c641f0077cd" providerId="LiveId" clId="{6DEDCE68-9D2E-4C8C-9998-BD219A3A306C}" dt="2026-01-12T23:41:23.086" v="1" actId="165"/>
-          <ac:spMkLst>
-            <pc:docMk/>
-            <pc:sldMk cId="715583163" sldId="260"/>
-            <ac:spMk id="43" creationId="{DB104DAC-DF16-6F8D-C1B0-15544809ED75}"/>
-          </ac:spMkLst>
-        </pc:spChg>
-        <pc:spChg chg="mod topLvl">
-          <ac:chgData name="Daniel Bauman" userId="b4990c641f0077cd" providerId="LiveId" clId="{6DEDCE68-9D2E-4C8C-9998-BD219A3A306C}" dt="2026-01-12T23:41:23.086" v="1" actId="165"/>
-          <ac:spMkLst>
-            <pc:docMk/>
-            <pc:sldMk cId="715583163" sldId="260"/>
-            <ac:spMk id="46" creationId="{6B2D3142-9DF6-1ECF-F829-ED4824C1D9CC}"/>
-          </ac:spMkLst>
-        </pc:spChg>
-        <pc:spChg chg="mod">
-          <ac:chgData name="Daniel Bauman" userId="b4990c641f0077cd" providerId="LiveId" clId="{6DEDCE68-9D2E-4C8C-9998-BD219A3A306C}" dt="2026-01-12T23:42:48.671" v="14" actId="1076"/>
-          <ac:spMkLst>
-            <pc:docMk/>
-            <pc:sldMk cId="715583163" sldId="260"/>
-            <ac:spMk id="47" creationId="{4CA26644-B23F-8405-C671-4FF35A354ECE}"/>
-          </ac:spMkLst>
-        </pc:spChg>
-        <pc:spChg chg="mod topLvl">
-          <ac:chgData name="Daniel Bauman" userId="b4990c641f0077cd" providerId="LiveId" clId="{6DEDCE68-9D2E-4C8C-9998-BD219A3A306C}" dt="2026-01-12T23:41:23.086" v="1" actId="165"/>
-          <ac:spMkLst>
-            <pc:docMk/>
-            <pc:sldMk cId="715583163" sldId="260"/>
-            <ac:spMk id="56" creationId="{56F0C9ED-1882-EA69-F3B1-CE547730C3EE}"/>
-          </ac:spMkLst>
-        </pc:spChg>
-        <pc:spChg chg="mod topLvl">
-          <ac:chgData name="Daniel Bauman" userId="b4990c641f0077cd" providerId="LiveId" clId="{6DEDCE68-9D2E-4C8C-9998-BD219A3A306C}" dt="2026-01-12T23:41:23.086" v="1" actId="165"/>
-          <ac:spMkLst>
-            <pc:docMk/>
-            <pc:sldMk cId="715583163" sldId="260"/>
-            <ac:spMk id="59" creationId="{779D2B87-31F1-BC0C-8F36-7EB9D95784AF}"/>
-          </ac:spMkLst>
-        </pc:spChg>
-        <pc:spChg chg="mod topLvl">
-          <ac:chgData name="Daniel Bauman" userId="b4990c641f0077cd" providerId="LiveId" clId="{6DEDCE68-9D2E-4C8C-9998-BD219A3A306C}" dt="2026-01-12T23:41:23.086" v="1" actId="165"/>
-          <ac:spMkLst>
-            <pc:docMk/>
-            <pc:sldMk cId="715583163" sldId="260"/>
-            <ac:spMk id="62" creationId="{6C84EE0F-2C3B-5118-5CFE-AB599AF16686}"/>
-          </ac:spMkLst>
-        </pc:spChg>
-        <pc:spChg chg="mod topLvl">
-          <ac:chgData name="Daniel Bauman" userId="b4990c641f0077cd" providerId="LiveId" clId="{6DEDCE68-9D2E-4C8C-9998-BD219A3A306C}" dt="2026-01-12T23:41:23.086" v="1" actId="165"/>
-          <ac:spMkLst>
-            <pc:docMk/>
-            <pc:sldMk cId="715583163" sldId="260"/>
-            <ac:spMk id="64" creationId="{001216A3-985C-6AC1-DE92-32C827B04218}"/>
-          </ac:spMkLst>
-        </pc:spChg>
-        <pc:grpChg chg="mod">
-          <ac:chgData name="Daniel Bauman" userId="b4990c641f0077cd" providerId="LiveId" clId="{6DEDCE68-9D2E-4C8C-9998-BD219A3A306C}" dt="2026-01-12T23:43:54.777" v="17" actId="14100"/>
-          <ac:grpSpMkLst>
-            <pc:docMk/>
-            <pc:sldMk cId="715583163" sldId="260"/>
-            <ac:grpSpMk id="15" creationId="{B8117478-55F4-D299-F74F-DA4E7B50B395}"/>
-          </ac:grpSpMkLst>
-        </pc:grpChg>
-        <pc:grpChg chg="mod">
-          <ac:chgData name="Daniel Bauman" userId="b4990c641f0077cd" providerId="LiveId" clId="{6DEDCE68-9D2E-4C8C-9998-BD219A3A306C}" dt="2026-01-12T23:43:54.777" v="17" actId="14100"/>
-          <ac:grpSpMkLst>
-            <pc:docMk/>
-            <pc:sldMk cId="715583163" sldId="260"/>
-            <ac:grpSpMk id="38" creationId="{C074FAD4-F15B-F77B-5884-7A823A2E4F94}"/>
-          </ac:grpSpMkLst>
-        </pc:grpChg>
-        <pc:cxnChg chg="mod topLvl">
-          <ac:chgData name="Daniel Bauman" userId="b4990c641f0077cd" providerId="LiveId" clId="{6DEDCE68-9D2E-4C8C-9998-BD219A3A306C}" dt="2026-01-12T23:44:04.012" v="18" actId="165"/>
-          <ac:cxnSpMkLst>
-            <pc:docMk/>
-            <pc:sldMk cId="715583163" sldId="260"/>
-            <ac:cxnSpMk id="24" creationId="{6983D89C-B472-4A1C-29B6-2171366662AD}"/>
-          </ac:cxnSpMkLst>
-        </pc:cxnChg>
-        <pc:cxnChg chg="mod">
-          <ac:chgData name="Daniel Bauman" userId="b4990c641f0077cd" providerId="LiveId" clId="{6DEDCE68-9D2E-4C8C-9998-BD219A3A306C}" dt="2026-01-12T23:44:35.813" v="22" actId="1076"/>
-          <ac:cxnSpMkLst>
-            <pc:docMk/>
-            <pc:sldMk cId="715583163" sldId="260"/>
-            <ac:cxnSpMk id="27" creationId="{43E9D88B-C81C-EB6A-D91D-772DBC62D46B}"/>
-          </ac:cxnSpMkLst>
-        </pc:cxnChg>
-        <pc:cxnChg chg="mod topLvl">
-          <ac:chgData name="Daniel Bauman" userId="b4990c641f0077cd" providerId="LiveId" clId="{6DEDCE68-9D2E-4C8C-9998-BD219A3A306C}" dt="2026-01-12T23:44:14.205" v="19" actId="165"/>
-          <ac:cxnSpMkLst>
-            <pc:docMk/>
-            <pc:sldMk cId="715583163" sldId="260"/>
-            <ac:cxnSpMk id="33" creationId="{A3AF3716-7977-11C4-39C1-B919A4A03960}"/>
-          </ac:cxnSpMkLst>
-        </pc:cxnChg>
-        <pc:cxnChg chg="mod topLvl">
-          <ac:chgData name="Daniel Bauman" userId="b4990c641f0077cd" providerId="LiveId" clId="{6DEDCE68-9D2E-4C8C-9998-BD219A3A306C}" dt="2026-01-12T23:44:14.205" v="19" actId="165"/>
-          <ac:cxnSpMkLst>
-            <pc:docMk/>
-            <pc:sldMk cId="715583163" sldId="260"/>
-            <ac:cxnSpMk id="34" creationId="{08D1E583-C08A-5B55-4798-7314ED323284}"/>
-          </ac:cxnSpMkLst>
-        </pc:cxnChg>
-      </pc:sldChg>
-      <pc:sldChg chg="addSp delSp modSp new mod">
-        <pc:chgData name="Daniel Bauman" userId="b4990c641f0077cd" providerId="LiveId" clId="{6DEDCE68-9D2E-4C8C-9998-BD219A3A306C}" dt="2026-01-13T00:00:35.081" v="217" actId="1076"/>
-        <pc:sldMkLst>
-          <pc:docMk/>
-          <pc:sldMk cId="4290982170" sldId="261"/>
-        </pc:sldMkLst>
-        <pc:spChg chg="add mod">
-          <ac:chgData name="Daniel Bauman" userId="b4990c641f0077cd" providerId="LiveId" clId="{6DEDCE68-9D2E-4C8C-9998-BD219A3A306C}" dt="2026-01-12T23:58:05.525" v="200" actId="164"/>
-          <ac:spMkLst>
-            <pc:docMk/>
-            <pc:sldMk cId="4290982170" sldId="261"/>
-            <ac:spMk id="4" creationId="{C9B7B1A1-72EB-8BCA-0D7C-77B1073DF71B}"/>
-          </ac:spMkLst>
-        </pc:spChg>
-        <pc:spChg chg="add mod">
-          <ac:chgData name="Daniel Bauman" userId="b4990c641f0077cd" providerId="LiveId" clId="{6DEDCE68-9D2E-4C8C-9998-BD219A3A306C}" dt="2026-01-12T23:58:05.525" v="200" actId="164"/>
-          <ac:spMkLst>
-            <pc:docMk/>
-            <pc:sldMk cId="4290982170" sldId="261"/>
-            <ac:spMk id="12" creationId="{F5F802EE-7CCF-BF99-DDD7-61AA40B6E25D}"/>
-          </ac:spMkLst>
-        </pc:spChg>
-        <pc:spChg chg="add mod ord">
-          <ac:chgData name="Daniel Bauman" userId="b4990c641f0077cd" providerId="LiveId" clId="{6DEDCE68-9D2E-4C8C-9998-BD219A3A306C}" dt="2026-01-12T23:58:05.525" v="200" actId="164"/>
-          <ac:spMkLst>
-            <pc:docMk/>
-            <pc:sldMk cId="4290982170" sldId="261"/>
-            <ac:spMk id="13" creationId="{203EC756-43D9-A6BE-601A-707126A769B8}"/>
-          </ac:spMkLst>
-        </pc:spChg>
-        <pc:spChg chg="add mod">
-          <ac:chgData name="Daniel Bauman" userId="b4990c641f0077cd" providerId="LiveId" clId="{6DEDCE68-9D2E-4C8C-9998-BD219A3A306C}" dt="2026-01-12T23:58:05.525" v="200" actId="164"/>
-          <ac:spMkLst>
-            <pc:docMk/>
-            <pc:sldMk cId="4290982170" sldId="261"/>
-            <ac:spMk id="14" creationId="{9AB5D0BC-9C04-7420-6A34-80330E9B713C}"/>
-          </ac:spMkLst>
-        </pc:spChg>
-        <pc:spChg chg="add mod ord">
-          <ac:chgData name="Daniel Bauman" userId="b4990c641f0077cd" providerId="LiveId" clId="{6DEDCE68-9D2E-4C8C-9998-BD219A3A306C}" dt="2026-01-12T23:58:05.525" v="200" actId="164"/>
-          <ac:spMkLst>
-            <pc:docMk/>
-            <pc:sldMk cId="4290982170" sldId="261"/>
-            <ac:spMk id="15" creationId="{67FDEF06-A581-9B69-6B94-8DA788EE3BB0}"/>
-          </ac:spMkLst>
-        </pc:spChg>
-        <pc:spChg chg="add mod">
-          <ac:chgData name="Daniel Bauman" userId="b4990c641f0077cd" providerId="LiveId" clId="{6DEDCE68-9D2E-4C8C-9998-BD219A3A306C}" dt="2026-01-12T23:58:05.525" v="200" actId="164"/>
-          <ac:spMkLst>
-            <pc:docMk/>
-            <pc:sldMk cId="4290982170" sldId="261"/>
-            <ac:spMk id="33" creationId="{E19917B3-CD2E-E00A-259B-FAD245217231}"/>
-          </ac:spMkLst>
-        </pc:spChg>
-        <pc:spChg chg="add mod">
-          <ac:chgData name="Daniel Bauman" userId="b4990c641f0077cd" providerId="LiveId" clId="{6DEDCE68-9D2E-4C8C-9998-BD219A3A306C}" dt="2026-01-12T23:58:05.525" v="200" actId="164"/>
-          <ac:spMkLst>
-            <pc:docMk/>
-            <pc:sldMk cId="4290982170" sldId="261"/>
-            <ac:spMk id="34" creationId="{6EA17E5F-A0B3-397E-FCAB-D25CB8BEDAD7}"/>
-          </ac:spMkLst>
-        </pc:spChg>
-        <pc:spChg chg="add mod">
-          <ac:chgData name="Daniel Bauman" userId="b4990c641f0077cd" providerId="LiveId" clId="{6DEDCE68-9D2E-4C8C-9998-BD219A3A306C}" dt="2026-01-12T23:58:05.525" v="200" actId="164"/>
-          <ac:spMkLst>
-            <pc:docMk/>
-            <pc:sldMk cId="4290982170" sldId="261"/>
-            <ac:spMk id="36" creationId="{E41D58EC-4340-1563-3598-9E89D1941F35}"/>
-          </ac:spMkLst>
-        </pc:spChg>
-        <pc:spChg chg="add mod">
-          <ac:chgData name="Daniel Bauman" userId="b4990c641f0077cd" providerId="LiveId" clId="{6DEDCE68-9D2E-4C8C-9998-BD219A3A306C}" dt="2026-01-12T23:58:05.525" v="200" actId="164"/>
-          <ac:spMkLst>
-            <pc:docMk/>
-            <pc:sldMk cId="4290982170" sldId="261"/>
-            <ac:spMk id="40" creationId="{FD564555-866E-6A12-4D59-B4DB116D735B}"/>
-          </ac:spMkLst>
-        </pc:spChg>
-        <pc:spChg chg="add mod">
-          <ac:chgData name="Daniel Bauman" userId="b4990c641f0077cd" providerId="LiveId" clId="{6DEDCE68-9D2E-4C8C-9998-BD219A3A306C}" dt="2026-01-12T23:57:57.420" v="199" actId="164"/>
-          <ac:spMkLst>
-            <pc:docMk/>
-            <pc:sldMk cId="4290982170" sldId="261"/>
-            <ac:spMk id="42" creationId="{A860037B-6C94-0ED9-753A-E1E1DC1D9D39}"/>
-          </ac:spMkLst>
-        </pc:spChg>
-        <pc:spChg chg="add mod">
-          <ac:chgData name="Daniel Bauman" userId="b4990c641f0077cd" providerId="LiveId" clId="{6DEDCE68-9D2E-4C8C-9998-BD219A3A306C}" dt="2026-01-12T23:57:57.420" v="199" actId="164"/>
-          <ac:spMkLst>
-            <pc:docMk/>
-            <pc:sldMk cId="4290982170" sldId="261"/>
-            <ac:spMk id="47" creationId="{127C1DC0-90AC-C245-1337-2484E69E7BF2}"/>
-          </ac:spMkLst>
-        </pc:spChg>
-        <pc:spChg chg="add mod">
-          <ac:chgData name="Daniel Bauman" userId="b4990c641f0077cd" providerId="LiveId" clId="{6DEDCE68-9D2E-4C8C-9998-BD219A3A306C}" dt="2026-01-12T23:57:57.420" v="199" actId="164"/>
-          <ac:spMkLst>
-            <pc:docMk/>
-            <pc:sldMk cId="4290982170" sldId="261"/>
-            <ac:spMk id="51" creationId="{3AA8DC02-AC99-E77F-3A1D-FBCA35C27AF0}"/>
-          </ac:spMkLst>
-        </pc:spChg>
-        <pc:spChg chg="add mod">
-          <ac:chgData name="Daniel Bauman" userId="b4990c641f0077cd" providerId="LiveId" clId="{6DEDCE68-9D2E-4C8C-9998-BD219A3A306C}" dt="2026-01-12T23:57:57.420" v="199" actId="164"/>
-          <ac:spMkLst>
-            <pc:docMk/>
-            <pc:sldMk cId="4290982170" sldId="261"/>
-            <ac:spMk id="52" creationId="{5B48E297-3142-9B6F-A97E-67106C2AE1FA}"/>
-          </ac:spMkLst>
-        </pc:spChg>
-        <pc:spChg chg="add mod">
-          <ac:chgData name="Daniel Bauman" userId="b4990c641f0077cd" providerId="LiveId" clId="{6DEDCE68-9D2E-4C8C-9998-BD219A3A306C}" dt="2026-01-12T23:57:57.420" v="199" actId="164"/>
-          <ac:spMkLst>
-            <pc:docMk/>
-            <pc:sldMk cId="4290982170" sldId="261"/>
-            <ac:spMk id="54" creationId="{1BC92B10-973E-CA10-4D81-427557084780}"/>
-          </ac:spMkLst>
-        </pc:spChg>
-        <pc:spChg chg="add mod">
-          <ac:chgData name="Daniel Bauman" userId="b4990c641f0077cd" providerId="LiveId" clId="{6DEDCE68-9D2E-4C8C-9998-BD219A3A306C}" dt="2026-01-12T23:57:57.420" v="199" actId="164"/>
-          <ac:spMkLst>
-            <pc:docMk/>
-            <pc:sldMk cId="4290982170" sldId="261"/>
-            <ac:spMk id="55" creationId="{042F27CF-D4C4-9CE0-45A5-C1AE26F6501D}"/>
-          </ac:spMkLst>
-        </pc:spChg>
-        <pc:spChg chg="add mod">
-          <ac:chgData name="Daniel Bauman" userId="b4990c641f0077cd" providerId="LiveId" clId="{6DEDCE68-9D2E-4C8C-9998-BD219A3A306C}" dt="2026-01-12T23:57:57.420" v="199" actId="164"/>
-          <ac:spMkLst>
-            <pc:docMk/>
-            <pc:sldMk cId="4290982170" sldId="261"/>
-            <ac:spMk id="56" creationId="{24A7858D-D176-7CBE-EB6A-6A7A8CD5FD24}"/>
-          </ac:spMkLst>
-        </pc:spChg>
-        <pc:spChg chg="add mod">
-          <ac:chgData name="Daniel Bauman" userId="b4990c641f0077cd" providerId="LiveId" clId="{6DEDCE68-9D2E-4C8C-9998-BD219A3A306C}" dt="2026-01-12T23:57:42.634" v="197" actId="164"/>
-          <ac:spMkLst>
-            <pc:docMk/>
-            <pc:sldMk cId="4290982170" sldId="261"/>
-            <ac:spMk id="63" creationId="{6A8A1C72-3E0E-54B4-7AC6-048554049530}"/>
-          </ac:spMkLst>
-        </pc:spChg>
-        <pc:spChg chg="add mod">
-          <ac:chgData name="Daniel Bauman" userId="b4990c641f0077cd" providerId="LiveId" clId="{6DEDCE68-9D2E-4C8C-9998-BD219A3A306C}" dt="2026-01-12T23:57:42.634" v="197" actId="164"/>
-          <ac:spMkLst>
-            <pc:docMk/>
-            <pc:sldMk cId="4290982170" sldId="261"/>
-            <ac:spMk id="64" creationId="{2F05083E-6B91-2D2A-9845-8C16AF5D8217}"/>
-          </ac:spMkLst>
-        </pc:spChg>
-        <pc:spChg chg="add mod">
-          <ac:chgData name="Daniel Bauman" userId="b4990c641f0077cd" providerId="LiveId" clId="{6DEDCE68-9D2E-4C8C-9998-BD219A3A306C}" dt="2026-01-12T23:57:42.634" v="197" actId="164"/>
-          <ac:spMkLst>
-            <pc:docMk/>
-            <pc:sldMk cId="4290982170" sldId="261"/>
-            <ac:spMk id="66" creationId="{6149F712-0674-9680-8C3A-14CEA6BF1D85}"/>
-          </ac:spMkLst>
-        </pc:spChg>
-        <pc:spChg chg="add mod">
-          <ac:chgData name="Daniel Bauman" userId="b4990c641f0077cd" providerId="LiveId" clId="{6DEDCE68-9D2E-4C8C-9998-BD219A3A306C}" dt="2026-01-12T23:57:42.634" v="197" actId="164"/>
-          <ac:spMkLst>
-            <pc:docMk/>
-            <pc:sldMk cId="4290982170" sldId="261"/>
-            <ac:spMk id="67" creationId="{86A1FE2B-FA75-FA0B-4F32-F343EDF91172}"/>
-          </ac:spMkLst>
-        </pc:spChg>
-        <pc:spChg chg="add mod">
-          <ac:chgData name="Daniel Bauman" userId="b4990c641f0077cd" providerId="LiveId" clId="{6DEDCE68-9D2E-4C8C-9998-BD219A3A306C}" dt="2026-01-12T23:57:42.634" v="197" actId="164"/>
-          <ac:spMkLst>
-            <pc:docMk/>
-            <pc:sldMk cId="4290982170" sldId="261"/>
-            <ac:spMk id="68" creationId="{6EA890EA-51B4-3843-D851-78DDCEF59FF8}"/>
-          </ac:spMkLst>
-        </pc:spChg>
-        <pc:spChg chg="add mod">
-          <ac:chgData name="Daniel Bauman" userId="b4990c641f0077cd" providerId="LiveId" clId="{6DEDCE68-9D2E-4C8C-9998-BD219A3A306C}" dt="2026-01-12T23:57:48.357" v="198" actId="164"/>
-          <ac:spMkLst>
-            <pc:docMk/>
-            <pc:sldMk cId="4290982170" sldId="261"/>
-            <ac:spMk id="70" creationId="{A02130FE-CE03-74AC-196C-3904DB72F796}"/>
-          </ac:spMkLst>
-        </pc:spChg>
-        <pc:spChg chg="add mod">
-          <ac:chgData name="Daniel Bauman" userId="b4990c641f0077cd" providerId="LiveId" clId="{6DEDCE68-9D2E-4C8C-9998-BD219A3A306C}" dt="2026-01-12T23:57:48.357" v="198" actId="164"/>
-          <ac:spMkLst>
-            <pc:docMk/>
-            <pc:sldMk cId="4290982170" sldId="261"/>
-            <ac:spMk id="71" creationId="{2BF028DE-22B9-F788-7624-328CA5B9EC2D}"/>
-          </ac:spMkLst>
-        </pc:spChg>
-        <pc:spChg chg="add mod">
-          <ac:chgData name="Daniel Bauman" userId="b4990c641f0077cd" providerId="LiveId" clId="{6DEDCE68-9D2E-4C8C-9998-BD219A3A306C}" dt="2026-01-12T23:57:48.357" v="198" actId="164"/>
-          <ac:spMkLst>
-            <pc:docMk/>
-            <pc:sldMk cId="4290982170" sldId="261"/>
-            <ac:spMk id="73" creationId="{F2927191-C52F-8E62-B001-2F2371444795}"/>
-          </ac:spMkLst>
-        </pc:spChg>
-        <pc:spChg chg="add mod">
-          <ac:chgData name="Daniel Bauman" userId="b4990c641f0077cd" providerId="LiveId" clId="{6DEDCE68-9D2E-4C8C-9998-BD219A3A306C}" dt="2026-01-12T23:59:56.677" v="213" actId="1076"/>
-          <ac:spMkLst>
-            <pc:docMk/>
-            <pc:sldMk cId="4290982170" sldId="261"/>
-            <ac:spMk id="83" creationId="{B07D8358-866E-7DC8-F5B2-32CF9C1AF490}"/>
-          </ac:spMkLst>
-        </pc:spChg>
-        <pc:spChg chg="add mod">
-          <ac:chgData name="Daniel Bauman" userId="b4990c641f0077cd" providerId="LiveId" clId="{6DEDCE68-9D2E-4C8C-9998-BD219A3A306C}" dt="2026-01-13T00:00:25.175" v="215" actId="1076"/>
-          <ac:spMkLst>
-            <pc:docMk/>
-            <pc:sldMk cId="4290982170" sldId="261"/>
-            <ac:spMk id="84" creationId="{6BE82CC7-4671-5EE1-0972-A9ECE609321A}"/>
-          </ac:spMkLst>
-        </pc:spChg>
-        <pc:spChg chg="add mod">
-          <ac:chgData name="Daniel Bauman" userId="b4990c641f0077cd" providerId="LiveId" clId="{6DEDCE68-9D2E-4C8C-9998-BD219A3A306C}" dt="2026-01-13T00:00:30.320" v="216" actId="1076"/>
-          <ac:spMkLst>
-            <pc:docMk/>
-            <pc:sldMk cId="4290982170" sldId="261"/>
-            <ac:spMk id="86" creationId="{6929A6C2-C445-45E1-FCC2-9C0CF8234D63}"/>
-          </ac:spMkLst>
-        </pc:spChg>
-        <pc:spChg chg="add mod">
-          <ac:chgData name="Daniel Bauman" userId="b4990c641f0077cd" providerId="LiveId" clId="{6DEDCE68-9D2E-4C8C-9998-BD219A3A306C}" dt="2026-01-13T00:00:35.081" v="217" actId="1076"/>
-          <ac:spMkLst>
-            <pc:docMk/>
-            <pc:sldMk cId="4290982170" sldId="261"/>
-            <ac:spMk id="87" creationId="{C707C6BA-B5FE-CB8A-8CD2-03AD32883661}"/>
-          </ac:spMkLst>
-        </pc:spChg>
-        <pc:spChg chg="add mod">
-          <ac:chgData name="Daniel Bauman" userId="b4990c641f0077cd" providerId="LiveId" clId="{6DEDCE68-9D2E-4C8C-9998-BD219A3A306C}" dt="2026-01-13T00:00:13.475" v="214"/>
-          <ac:spMkLst>
-            <pc:docMk/>
-            <pc:sldMk cId="4290982170" sldId="261"/>
-            <ac:spMk id="89" creationId="{26340BBC-FE5F-7DE1-414A-F265C3EEDC8C}"/>
-          </ac:spMkLst>
-        </pc:spChg>
-        <pc:spChg chg="add mod">
-          <ac:chgData name="Daniel Bauman" userId="b4990c641f0077cd" providerId="LiveId" clId="{6DEDCE68-9D2E-4C8C-9998-BD219A3A306C}" dt="2026-01-13T00:00:13.475" v="214"/>
-          <ac:spMkLst>
-            <pc:docMk/>
-            <pc:sldMk cId="4290982170" sldId="261"/>
-            <ac:spMk id="90" creationId="{5BBE4C97-FA8B-EC42-A2A1-777C18B1FAD4}"/>
-          </ac:spMkLst>
-        </pc:spChg>
-        <pc:spChg chg="add mod">
-          <ac:chgData name="Daniel Bauman" userId="b4990c641f0077cd" providerId="LiveId" clId="{6DEDCE68-9D2E-4C8C-9998-BD219A3A306C}" dt="2026-01-13T00:00:13.475" v="214"/>
-          <ac:spMkLst>
-            <pc:docMk/>
-            <pc:sldMk cId="4290982170" sldId="261"/>
-            <ac:spMk id="91" creationId="{AF729F03-4974-45E9-EF85-E162DA1E82CB}"/>
-          </ac:spMkLst>
-        </pc:spChg>
-        <pc:spChg chg="add mod">
-          <ac:chgData name="Daniel Bauman" userId="b4990c641f0077cd" providerId="LiveId" clId="{6DEDCE68-9D2E-4C8C-9998-BD219A3A306C}" dt="2026-01-13T00:00:13.475" v="214"/>
-          <ac:spMkLst>
-            <pc:docMk/>
-            <pc:sldMk cId="4290982170" sldId="261"/>
-            <ac:spMk id="93" creationId="{56C035A7-43E7-4B8C-8D4F-31B68BF7AA79}"/>
-          </ac:spMkLst>
-        </pc:spChg>
-        <pc:spChg chg="add mod">
-          <ac:chgData name="Daniel Bauman" userId="b4990c641f0077cd" providerId="LiveId" clId="{6DEDCE68-9D2E-4C8C-9998-BD219A3A306C}" dt="2026-01-13T00:00:13.475" v="214"/>
-          <ac:spMkLst>
-            <pc:docMk/>
-            <pc:sldMk cId="4290982170" sldId="261"/>
-            <ac:spMk id="94" creationId="{F4C50C96-71B9-FF1F-B1E0-D372887C4A73}"/>
-          </ac:spMkLst>
-        </pc:spChg>
-        <pc:spChg chg="add mod">
-          <ac:chgData name="Daniel Bauman" userId="b4990c641f0077cd" providerId="LiveId" clId="{6DEDCE68-9D2E-4C8C-9998-BD219A3A306C}" dt="2026-01-13T00:00:13.475" v="214"/>
-          <ac:spMkLst>
-            <pc:docMk/>
-            <pc:sldMk cId="4290982170" sldId="261"/>
-            <ac:spMk id="95" creationId="{976DB453-863C-64B8-7B1F-5EB73935D0B6}"/>
-          </ac:spMkLst>
-        </pc:spChg>
-        <pc:spChg chg="add mod">
-          <ac:chgData name="Daniel Bauman" userId="b4990c641f0077cd" providerId="LiveId" clId="{6DEDCE68-9D2E-4C8C-9998-BD219A3A306C}" dt="2026-01-13T00:00:13.475" v="214"/>
-          <ac:spMkLst>
-            <pc:docMk/>
-            <pc:sldMk cId="4290982170" sldId="261"/>
-            <ac:spMk id="96" creationId="{A33BBE18-B1F2-F457-EE5C-7DD08EC5C8F5}"/>
-          </ac:spMkLst>
-        </pc:spChg>
-        <pc:grpChg chg="add mod">
-          <ac:chgData name="Daniel Bauman" userId="b4990c641f0077cd" providerId="LiveId" clId="{6DEDCE68-9D2E-4C8C-9998-BD219A3A306C}" dt="2026-01-12T23:58:28.258" v="201" actId="1076"/>
-          <ac:grpSpMkLst>
-            <pc:docMk/>
-            <pc:sldMk cId="4290982170" sldId="261"/>
-            <ac:grpSpMk id="77" creationId="{A40865E8-2062-B697-DB3F-572D44B21173}"/>
-          </ac:grpSpMkLst>
-        </pc:grpChg>
-        <pc:grpChg chg="add mod">
-          <ac:chgData name="Daniel Bauman" userId="b4990c641f0077cd" providerId="LiveId" clId="{6DEDCE68-9D2E-4C8C-9998-BD219A3A306C}" dt="2026-01-12T23:57:48.357" v="198" actId="164"/>
-          <ac:grpSpMkLst>
-            <pc:docMk/>
-            <pc:sldMk cId="4290982170" sldId="261"/>
-            <ac:grpSpMk id="78" creationId="{ABE1DED3-E515-C5AD-4ACC-1FA7BC56E767}"/>
-          </ac:grpSpMkLst>
-        </pc:grpChg>
-        <pc:grpChg chg="add mod">
-          <ac:chgData name="Daniel Bauman" userId="b4990c641f0077cd" providerId="LiveId" clId="{6DEDCE68-9D2E-4C8C-9998-BD219A3A306C}" dt="2026-01-12T23:59:00.327" v="204" actId="1076"/>
-          <ac:grpSpMkLst>
-            <pc:docMk/>
-            <pc:sldMk cId="4290982170" sldId="261"/>
-            <ac:grpSpMk id="79" creationId="{8DA2FEA8-BE6B-424C-A97C-00DC9E4DF1D7}"/>
-          </ac:grpSpMkLst>
-        </pc:grpChg>
-        <pc:grpChg chg="add mod">
-          <ac:chgData name="Daniel Bauman" userId="b4990c641f0077cd" providerId="LiveId" clId="{6DEDCE68-9D2E-4C8C-9998-BD219A3A306C}" dt="2026-01-12T23:58:52.921" v="203" actId="1076"/>
-          <ac:grpSpMkLst>
-            <pc:docMk/>
-            <pc:sldMk cId="4290982170" sldId="261"/>
-            <ac:grpSpMk id="80" creationId="{8132106A-80F7-0774-A926-3CEE4C922F40}"/>
-          </ac:grpSpMkLst>
-        </pc:grpChg>
-        <pc:cxnChg chg="mod">
-          <ac:chgData name="Daniel Bauman" userId="b4990c641f0077cd" providerId="LiveId" clId="{6DEDCE68-9D2E-4C8C-9998-BD219A3A306C}" dt="2026-01-12T23:48:08.715" v="61" actId="1076"/>
-          <ac:cxnSpMkLst>
-            <pc:docMk/>
-            <pc:sldMk cId="4290982170" sldId="261"/>
-            <ac:cxnSpMk id="3" creationId="{1D2B7D95-6CB6-63B8-E541-EC4FE3D469C4}"/>
-          </ac:cxnSpMkLst>
-        </pc:cxnChg>
-        <pc:cxnChg chg="add mod">
-          <ac:chgData name="Daniel Bauman" userId="b4990c641f0077cd" providerId="LiveId" clId="{6DEDCE68-9D2E-4C8C-9998-BD219A3A306C}" dt="2026-01-12T23:54:01.097" v="158" actId="1076"/>
-          <ac:cxnSpMkLst>
-            <pc:docMk/>
-            <pc:sldMk cId="4290982170" sldId="261"/>
-            <ac:cxnSpMk id="11" creationId="{D8CE16D1-3F5D-B8AD-BE92-337A39F80FAF}"/>
-          </ac:cxnSpMkLst>
-        </pc:cxnChg>
-        <pc:cxnChg chg="add mod">
-          <ac:chgData name="Daniel Bauman" userId="b4990c641f0077cd" providerId="LiveId" clId="{6DEDCE68-9D2E-4C8C-9998-BD219A3A306C}" dt="2026-01-12T23:51:42.253" v="132" actId="14100"/>
-          <ac:cxnSpMkLst>
-            <pc:docMk/>
-            <pc:sldMk cId="4290982170" sldId="261"/>
-            <ac:cxnSpMk id="19" creationId="{B7EF9838-E95B-1AE9-444B-E2DCEB80CEEE}"/>
-          </ac:cxnSpMkLst>
-        </pc:cxnChg>
-        <pc:cxnChg chg="add mod">
-          <ac:chgData name="Daniel Bauman" userId="b4990c641f0077cd" providerId="LiveId" clId="{6DEDCE68-9D2E-4C8C-9998-BD219A3A306C}" dt="2026-01-12T23:53:01.423" v="146" actId="1076"/>
-          <ac:cxnSpMkLst>
-            <pc:docMk/>
-            <pc:sldMk cId="4290982170" sldId="261"/>
-            <ac:cxnSpMk id="21" creationId="{AF5F2555-2855-A88A-C78A-E3BEE533F67A}"/>
-          </ac:cxnSpMkLst>
-        </pc:cxnChg>
-        <pc:cxnChg chg="add mod">
-          <ac:chgData name="Daniel Bauman" userId="b4990c641f0077cd" providerId="LiveId" clId="{6DEDCE68-9D2E-4C8C-9998-BD219A3A306C}" dt="2026-01-12T23:53:33.554" v="152" actId="14100"/>
-          <ac:cxnSpMkLst>
-            <pc:docMk/>
-            <pc:sldMk cId="4290982170" sldId="261"/>
-            <ac:cxnSpMk id="28" creationId="{8BF16D13-C5E3-22F5-681F-43DD3AF41A98}"/>
-          </ac:cxnSpMkLst>
-        </pc:cxnChg>
-        <pc:cxnChg chg="add mod">
-          <ac:chgData name="Daniel Bauman" userId="b4990c641f0077cd" providerId="LiveId" clId="{6DEDCE68-9D2E-4C8C-9998-BD219A3A306C}" dt="2026-01-12T23:52:44.487" v="141" actId="1076"/>
-          <ac:cxnSpMkLst>
-            <pc:docMk/>
-            <pc:sldMk cId="4290982170" sldId="261"/>
-            <ac:cxnSpMk id="32" creationId="{533CA66A-1F64-75DF-6534-41CFE4E064A7}"/>
-          </ac:cxnSpMkLst>
-        </pc:cxnChg>
-        <pc:cxnChg chg="add mod">
-          <ac:chgData name="Daniel Bauman" userId="b4990c641f0077cd" providerId="LiveId" clId="{6DEDCE68-9D2E-4C8C-9998-BD219A3A306C}" dt="2026-01-12T23:52:44.487" v="141" actId="1076"/>
-          <ac:cxnSpMkLst>
-            <pc:docMk/>
-            <pc:sldMk cId="4290982170" sldId="261"/>
-            <ac:cxnSpMk id="35" creationId="{FFB0913D-B48C-84A4-1F6E-9497D390B461}"/>
-          </ac:cxnSpMkLst>
-        </pc:cxnChg>
-        <pc:cxnChg chg="mod">
-          <ac:chgData name="Daniel Bauman" userId="b4990c641f0077cd" providerId="LiveId" clId="{6DEDCE68-9D2E-4C8C-9998-BD219A3A306C}" dt="2026-01-12T23:55:30.528" v="175" actId="14100"/>
-          <ac:cxnSpMkLst>
-            <pc:docMk/>
-            <pc:sldMk cId="4290982170" sldId="261"/>
-            <ac:cxnSpMk id="41" creationId="{3528B99B-A1B3-FDCE-EEFB-AAD81A7A34A7}"/>
-          </ac:cxnSpMkLst>
-        </pc:cxnChg>
-        <pc:cxnChg chg="mod">
-          <ac:chgData name="Daniel Bauman" userId="b4990c641f0077cd" providerId="LiveId" clId="{6DEDCE68-9D2E-4C8C-9998-BD219A3A306C}" dt="2026-01-12T23:54:53.917" v="167" actId="14100"/>
-          <ac:cxnSpMkLst>
-            <pc:docMk/>
-            <pc:sldMk cId="4290982170" sldId="261"/>
-            <ac:cxnSpMk id="48" creationId="{DC086589-EA29-640C-ADFC-28472E6E3DEA}"/>
-          </ac:cxnSpMkLst>
-        </pc:cxnChg>
-        <pc:cxnChg chg="add mod">
-          <ac:chgData name="Daniel Bauman" userId="b4990c641f0077cd" providerId="LiveId" clId="{6DEDCE68-9D2E-4C8C-9998-BD219A3A306C}" dt="2026-01-12T23:57:57.420" v="199" actId="164"/>
-          <ac:cxnSpMkLst>
-            <pc:docMk/>
-            <pc:sldMk cId="4290982170" sldId="261"/>
-            <ac:cxnSpMk id="50" creationId="{FCD34A22-B524-750B-EA7C-F154C5C630B2}"/>
-          </ac:cxnSpMkLst>
-        </pc:cxnChg>
-        <pc:cxnChg chg="mod">
-          <ac:chgData name="Daniel Bauman" userId="b4990c641f0077cd" providerId="LiveId" clId="{6DEDCE68-9D2E-4C8C-9998-BD219A3A306C}" dt="2026-01-12T23:57:57.420" v="199" actId="164"/>
-          <ac:cxnSpMkLst>
-            <pc:docMk/>
-            <pc:sldMk cId="4290982170" sldId="261"/>
-            <ac:cxnSpMk id="53" creationId="{777BB286-CA49-DA39-5381-E1B3CFDFE929}"/>
-          </ac:cxnSpMkLst>
-        </pc:cxnChg>
-        <pc:cxnChg chg="add mod">
-          <ac:chgData name="Daniel Bauman" userId="b4990c641f0077cd" providerId="LiveId" clId="{6DEDCE68-9D2E-4C8C-9998-BD219A3A306C}" dt="2026-01-12T23:57:42.634" v="197" actId="164"/>
-          <ac:cxnSpMkLst>
-            <pc:docMk/>
-            <pc:sldMk cId="4290982170" sldId="261"/>
-            <ac:cxnSpMk id="61" creationId="{D76F8045-4AD8-3F5B-B25B-4F5320B18F53}"/>
-          </ac:cxnSpMkLst>
-        </pc:cxnChg>
-        <pc:cxnChg chg="add mod">
-          <ac:chgData name="Daniel Bauman" userId="b4990c641f0077cd" providerId="LiveId" clId="{6DEDCE68-9D2E-4C8C-9998-BD219A3A306C}" dt="2026-01-12T23:57:42.634" v="197" actId="164"/>
-          <ac:cxnSpMkLst>
-            <pc:docMk/>
-            <pc:sldMk cId="4290982170" sldId="261"/>
-            <ac:cxnSpMk id="62" creationId="{6D72B4B0-E124-7907-13BB-38793C46096A}"/>
-          </ac:cxnSpMkLst>
-        </pc:cxnChg>
-        <pc:cxnChg chg="add mod">
-          <ac:chgData name="Daniel Bauman" userId="b4990c641f0077cd" providerId="LiveId" clId="{6DEDCE68-9D2E-4C8C-9998-BD219A3A306C}" dt="2026-01-12T23:57:42.634" v="197" actId="164"/>
-          <ac:cxnSpMkLst>
-            <pc:docMk/>
-            <pc:sldMk cId="4290982170" sldId="261"/>
-            <ac:cxnSpMk id="65" creationId="{97553787-5605-2085-1221-B795405B7A69}"/>
-          </ac:cxnSpMkLst>
-        </pc:cxnChg>
-        <pc:cxnChg chg="add mod">
-          <ac:chgData name="Daniel Bauman" userId="b4990c641f0077cd" providerId="LiveId" clId="{6DEDCE68-9D2E-4C8C-9998-BD219A3A306C}" dt="2026-01-12T23:57:48.357" v="198" actId="164"/>
-          <ac:cxnSpMkLst>
-            <pc:docMk/>
-            <pc:sldMk cId="4290982170" sldId="261"/>
-            <ac:cxnSpMk id="69" creationId="{ADF802CE-4C04-8DAF-7A7F-063620E625C4}"/>
-          </ac:cxnSpMkLst>
-        </pc:cxnChg>
-        <pc:cxnChg chg="add mod">
-          <ac:chgData name="Daniel Bauman" userId="b4990c641f0077cd" providerId="LiveId" clId="{6DEDCE68-9D2E-4C8C-9998-BD219A3A306C}" dt="2026-01-12T23:57:48.357" v="198" actId="164"/>
-          <ac:cxnSpMkLst>
-            <pc:docMk/>
-            <pc:sldMk cId="4290982170" sldId="261"/>
-            <ac:cxnSpMk id="72" creationId="{B7F66CE9-94DA-9826-EF80-71AD9E456CFA}"/>
-          </ac:cxnSpMkLst>
-        </pc:cxnChg>
-      </pc:sldChg>
-      <pc:sldChg chg="addSp delSp modSp add mod">
-        <pc:chgData name="Daniel Bauman" userId="b4990c641f0077cd" providerId="LiveId" clId="{6DEDCE68-9D2E-4C8C-9998-BD219A3A306C}" dt="2026-01-21T05:25:19.192" v="258" actId="20577"/>
-        <pc:sldMkLst>
-          <pc:docMk/>
-          <pc:sldMk cId="413350594" sldId="262"/>
-        </pc:sldMkLst>
-        <pc:spChg chg="mod">
-          <ac:chgData name="Daniel Bauman" userId="b4990c641f0077cd" providerId="LiveId" clId="{6DEDCE68-9D2E-4C8C-9998-BD219A3A306C}" dt="2026-01-21T05:25:19.192" v="258" actId="20577"/>
-          <ac:spMkLst>
-            <pc:docMk/>
-            <pc:sldMk cId="413350594" sldId="262"/>
-            <ac:spMk id="2" creationId="{707BFED8-B447-57C8-033D-FC0421618995}"/>
-          </ac:spMkLst>
-        </pc:spChg>
-        <pc:spChg chg="mod">
-          <ac:chgData name="Daniel Bauman" userId="b4990c641f0077cd" providerId="LiveId" clId="{6DEDCE68-9D2E-4C8C-9998-BD219A3A306C}" dt="2026-01-21T05:25:14.724" v="254" actId="20577"/>
-          <ac:spMkLst>
-            <pc:docMk/>
-            <pc:sldMk cId="413350594" sldId="262"/>
-            <ac:spMk id="6" creationId="{0D8B1CE7-D220-8B65-BB58-841601A815CD}"/>
-          </ac:spMkLst>
-        </pc:spChg>
-        <pc:spChg chg="mod">
-          <ac:chgData name="Daniel Bauman" userId="b4990c641f0077cd" providerId="LiveId" clId="{6DEDCE68-9D2E-4C8C-9998-BD219A3A306C}" dt="2026-01-13T00:04:08.640" v="244" actId="14100"/>
-          <ac:spMkLst>
-            <pc:docMk/>
-            <pc:sldMk cId="413350594" sldId="262"/>
-            <ac:spMk id="7" creationId="{3B5E4F1E-DA06-D655-6A14-D7BD7557C355}"/>
-          </ac:spMkLst>
-        </pc:spChg>
-        <pc:spChg chg="mod">
-          <ac:chgData name="Daniel Bauman" userId="b4990c641f0077cd" providerId="LiveId" clId="{6DEDCE68-9D2E-4C8C-9998-BD219A3A306C}" dt="2026-01-21T05:25:14.724" v="254" actId="20577"/>
-          <ac:spMkLst>
-            <pc:docMk/>
-            <pc:sldMk cId="413350594" sldId="262"/>
-            <ac:spMk id="8" creationId="{98305963-C95C-8861-CC7C-B30B2C97107F}"/>
-          </ac:spMkLst>
-        </pc:spChg>
-        <pc:spChg chg="mod">
-          <ac:chgData name="Daniel Bauman" userId="b4990c641f0077cd" providerId="LiveId" clId="{6DEDCE68-9D2E-4C8C-9998-BD219A3A306C}" dt="2026-01-21T05:25:19.192" v="258" actId="20577"/>
-          <ac:spMkLst>
-            <pc:docMk/>
-            <pc:sldMk cId="413350594" sldId="262"/>
-            <ac:spMk id="9" creationId="{C70792C5-09B5-9873-0B79-3E67050139AD}"/>
-          </ac:spMkLst>
-        </pc:spChg>
-        <pc:spChg chg="mod">
-          <ac:chgData name="Daniel Bauman" userId="b4990c641f0077cd" providerId="LiveId" clId="{6DEDCE68-9D2E-4C8C-9998-BD219A3A306C}" dt="2026-01-13T00:02:42.286" v="235" actId="13822"/>
-          <ac:spMkLst>
-            <pc:docMk/>
-            <pc:sldMk cId="413350594" sldId="262"/>
-            <ac:spMk id="12" creationId="{F2BD7315-F929-6E45-0773-7A7C6F568C3F}"/>
-          </ac:spMkLst>
-        </pc:spChg>
-        <pc:spChg chg="mod">
-          <ac:chgData name="Daniel Bauman" userId="b4990c641f0077cd" providerId="LiveId" clId="{6DEDCE68-9D2E-4C8C-9998-BD219A3A306C}" dt="2026-01-13T00:02:20.191" v="232" actId="20577"/>
-          <ac:spMkLst>
-            <pc:docMk/>
-            <pc:sldMk cId="413350594" sldId="262"/>
-            <ac:spMk id="18" creationId="{347E8468-80B3-F7B5-C12D-D7599610C986}"/>
-          </ac:spMkLst>
-        </pc:spChg>
-        <pc:spChg chg="mod">
-          <ac:chgData name="Daniel Bauman" userId="b4990c641f0077cd" providerId="LiveId" clId="{6DEDCE68-9D2E-4C8C-9998-BD219A3A306C}" dt="2026-01-21T05:25:19.192" v="258" actId="20577"/>
-          <ac:spMkLst>
-            <pc:docMk/>
-            <pc:sldMk cId="413350594" sldId="262"/>
-            <ac:spMk id="19" creationId="{8DA840A1-D639-D28F-627F-9BEABF3CFA69}"/>
-          </ac:spMkLst>
-        </pc:spChg>
-        <pc:spChg chg="mod">
-          <ac:chgData name="Daniel Bauman" userId="b4990c641f0077cd" providerId="LiveId" clId="{6DEDCE68-9D2E-4C8C-9998-BD219A3A306C}" dt="2026-01-21T05:25:19.192" v="258" actId="20577"/>
-          <ac:spMkLst>
-            <pc:docMk/>
-            <pc:sldMk cId="413350594" sldId="262"/>
-            <ac:spMk id="20" creationId="{E6BF1079-A48A-1B30-354C-39D05B8FCFF4}"/>
-          </ac:spMkLst>
-        </pc:spChg>
-        <pc:spChg chg="mod">
-          <ac:chgData name="Daniel Bauman" userId="b4990c641f0077cd" providerId="LiveId" clId="{6DEDCE68-9D2E-4C8C-9998-BD219A3A306C}" dt="2026-01-13T00:04:00.366" v="242" actId="165"/>
-          <ac:spMkLst>
-            <pc:docMk/>
-            <pc:sldMk cId="413350594" sldId="262"/>
-            <ac:spMk id="29" creationId="{AEDA0048-A047-B629-5440-4DFE39AB33E4}"/>
-          </ac:spMkLst>
-        </pc:spChg>
-        <pc:spChg chg="mod">
-          <ac:chgData name="Daniel Bauman" userId="b4990c641f0077cd" providerId="LiveId" clId="{6DEDCE68-9D2E-4C8C-9998-BD219A3A306C}" dt="2026-01-21T05:25:19.192" v="258" actId="20577"/>
-          <ac:spMkLst>
-            <pc:docMk/>
-            <pc:sldMk cId="413350594" sldId="262"/>
-            <ac:spMk id="30" creationId="{7919ABCD-A4F5-EB3E-9748-95FA57B6B805}"/>
-          </ac:spMkLst>
-        </pc:spChg>
-        <pc:spChg chg="mod">
-          <ac:chgData name="Daniel Bauman" userId="b4990c641f0077cd" providerId="LiveId" clId="{6DEDCE68-9D2E-4C8C-9998-BD219A3A306C}" dt="2026-01-21T05:25:19.192" v="258" actId="20577"/>
-          <ac:spMkLst>
-            <pc:docMk/>
-            <pc:sldMk cId="413350594" sldId="262"/>
-            <ac:spMk id="35" creationId="{83E429E3-E41E-74FD-BF6A-1E5915949BDE}"/>
-          </ac:spMkLst>
-        </pc:spChg>
-        <pc:spChg chg="mod">
-          <ac:chgData name="Daniel Bauman" userId="b4990c641f0077cd" providerId="LiveId" clId="{6DEDCE68-9D2E-4C8C-9998-BD219A3A306C}" dt="2026-01-13T00:04:00.366" v="242" actId="165"/>
-          <ac:spMkLst>
-            <pc:docMk/>
-            <pc:sldMk cId="413350594" sldId="262"/>
-            <ac:spMk id="36" creationId="{5D97F270-07E9-9673-E7BB-12095EFAF862}"/>
-          </ac:spMkLst>
-        </pc:spChg>
-        <pc:spChg chg="mod">
-          <ac:chgData name="Daniel Bauman" userId="b4990c641f0077cd" providerId="LiveId" clId="{6DEDCE68-9D2E-4C8C-9998-BD219A3A306C}" dt="2026-01-13T00:02:31.905" v="233" actId="207"/>
-          <ac:spMkLst>
-            <pc:docMk/>
-            <pc:sldMk cId="413350594" sldId="262"/>
-            <ac:spMk id="37" creationId="{62034F6B-8AAD-8FE7-F44F-B3EF88C92179}"/>
-          </ac:spMkLst>
-        </pc:spChg>
-        <pc:spChg chg="mod">
-          <ac:chgData name="Daniel Bauman" userId="b4990c641f0077cd" providerId="LiveId" clId="{6DEDCE68-9D2E-4C8C-9998-BD219A3A306C}" dt="2026-01-13T00:05:13.283" v="252" actId="164"/>
-          <ac:spMkLst>
-            <pc:docMk/>
-            <pc:sldMk cId="413350594" sldId="262"/>
-            <ac:spMk id="41" creationId="{7D2737DE-6859-4D07-61CE-02DD88CDA143}"/>
-          </ac:spMkLst>
-        </pc:spChg>
-        <pc:spChg chg="mod topLvl">
-          <ac:chgData name="Daniel Bauman" userId="b4990c641f0077cd" providerId="LiveId" clId="{6DEDCE68-9D2E-4C8C-9998-BD219A3A306C}" dt="2026-01-21T05:25:19.192" v="258" actId="20577"/>
-          <ac:spMkLst>
-            <pc:docMk/>
-            <pc:sldMk cId="413350594" sldId="262"/>
-            <ac:spMk id="42" creationId="{1D3FEEF6-E558-8108-B754-667B8C04C2BF}"/>
-          </ac:spMkLst>
-        </pc:spChg>
-        <pc:spChg chg="mod">
-          <ac:chgData name="Daniel Bauman" userId="b4990c641f0077cd" providerId="LiveId" clId="{6DEDCE68-9D2E-4C8C-9998-BD219A3A306C}" dt="2026-01-13T00:04:56.405" v="250" actId="1076"/>
-          <ac:spMkLst>
-            <pc:docMk/>
-            <pc:sldMk cId="413350594" sldId="262"/>
-            <ac:spMk id="46" creationId="{1483317C-3D61-512C-F9A2-43C03D9D8529}"/>
-          </ac:spMkLst>
-        </pc:spChg>
-        <pc:spChg chg="mod topLvl">
-          <ac:chgData name="Daniel Bauman" userId="b4990c641f0077cd" providerId="LiveId" clId="{6DEDCE68-9D2E-4C8C-9998-BD219A3A306C}" dt="2026-01-13T00:05:13.283" v="252" actId="164"/>
-          <ac:spMkLst>
-            <pc:docMk/>
-            <pc:sldMk cId="413350594" sldId="262"/>
-            <ac:spMk id="47" creationId="{40ACB0E9-8D82-D668-68A7-1D1068A40EDA}"/>
-          </ac:spMkLst>
-        </pc:spChg>
-        <pc:spChg chg="mod">
-          <ac:chgData name="Daniel Bauman" userId="b4990c641f0077cd" providerId="LiveId" clId="{6DEDCE68-9D2E-4C8C-9998-BD219A3A306C}" dt="2026-01-21T05:25:14.724" v="254" actId="20577"/>
-          <ac:spMkLst>
-            <pc:docMk/>
-            <pc:sldMk cId="413350594" sldId="262"/>
-            <ac:spMk id="54" creationId="{C928B158-BDBB-465E-A338-D1921C87417A}"/>
-          </ac:spMkLst>
-        </pc:spChg>
-        <pc:spChg chg="mod topLvl">
-          <ac:chgData name="Daniel Bauman" userId="b4990c641f0077cd" providerId="LiveId" clId="{6DEDCE68-9D2E-4C8C-9998-BD219A3A306C}" dt="2026-01-21T05:25:19.192" v="258" actId="20577"/>
-          <ac:spMkLst>
-            <pc:docMk/>
-            <pc:sldMk cId="413350594" sldId="262"/>
-            <ac:spMk id="55" creationId="{46E2F094-45C8-94C5-C786-6B43B277FBC8}"/>
-          </ac:spMkLst>
-        </pc:spChg>
-        <pc:spChg chg="mod">
-          <ac:chgData name="Daniel Bauman" userId="b4990c641f0077cd" providerId="LiveId" clId="{6DEDCE68-9D2E-4C8C-9998-BD219A3A306C}" dt="2026-01-21T05:25:19.192" v="258" actId="20577"/>
-          <ac:spMkLst>
-            <pc:docMk/>
-            <pc:sldMk cId="413350594" sldId="262"/>
-            <ac:spMk id="56" creationId="{D740D595-1F53-C3C5-56D3-24B192CA6023}"/>
-          </ac:spMkLst>
-        </pc:spChg>
-        <pc:spChg chg="mod topLvl">
-          <ac:chgData name="Daniel Bauman" userId="b4990c641f0077cd" providerId="LiveId" clId="{6DEDCE68-9D2E-4C8C-9998-BD219A3A306C}" dt="2026-01-21T05:25:14.724" v="254" actId="20577"/>
-          <ac:spMkLst>
-            <pc:docMk/>
-            <pc:sldMk cId="413350594" sldId="262"/>
-            <ac:spMk id="57" creationId="{E1F7D2D5-4E74-501D-5A75-300C4FEDB18C}"/>
-          </ac:spMkLst>
-        </pc:spChg>
-        <pc:spChg chg="mod">
-          <ac:chgData name="Daniel Bauman" userId="b4990c641f0077cd" providerId="LiveId" clId="{6DEDCE68-9D2E-4C8C-9998-BD219A3A306C}" dt="2026-01-13T00:02:20.191" v="232" actId="20577"/>
-          <ac:spMkLst>
-            <pc:docMk/>
-            <pc:sldMk cId="413350594" sldId="262"/>
-            <ac:spMk id="58" creationId="{074CC74D-8EBC-EA01-9F6F-51C04CB151B0}"/>
-          </ac:spMkLst>
-        </pc:spChg>
-        <pc:spChg chg="mod topLvl">
-          <ac:chgData name="Daniel Bauman" userId="b4990c641f0077cd" providerId="LiveId" clId="{6DEDCE68-9D2E-4C8C-9998-BD219A3A306C}" dt="2026-01-13T00:05:13.283" v="252" actId="164"/>
-          <ac:spMkLst>
-            <pc:docMk/>
-            <pc:sldMk cId="413350594" sldId="262"/>
-            <ac:spMk id="59" creationId="{58A5CF51-62D5-CB61-7452-79F44F904532}"/>
-          </ac:spMkLst>
-        </pc:spChg>
-        <pc:spChg chg="mod">
-          <ac:chgData name="Daniel Bauman" userId="b4990c641f0077cd" providerId="LiveId" clId="{6DEDCE68-9D2E-4C8C-9998-BD219A3A306C}" dt="2026-01-21T05:25:19.192" v="258" actId="20577"/>
-          <ac:spMkLst>
-            <pc:docMk/>
-            <pc:sldMk cId="413350594" sldId="262"/>
-            <ac:spMk id="60" creationId="{60D52E4E-B2F6-805F-CEF3-638EC693F6C2}"/>
-          </ac:spMkLst>
-        </pc:spChg>
-        <pc:spChg chg="mod">
-          <ac:chgData name="Daniel Bauman" userId="b4990c641f0077cd" providerId="LiveId" clId="{6DEDCE68-9D2E-4C8C-9998-BD219A3A306C}" dt="2026-01-21T05:25:14.724" v="254" actId="20577"/>
-          <ac:spMkLst>
-            <pc:docMk/>
-            <pc:sldMk cId="413350594" sldId="262"/>
-            <ac:spMk id="61" creationId="{5FD09119-A486-A2D8-0FD3-3CF9627811D2}"/>
-          </ac:spMkLst>
-        </pc:spChg>
-        <pc:spChg chg="mod">
-          <ac:chgData name="Daniel Bauman" userId="b4990c641f0077cd" providerId="LiveId" clId="{6DEDCE68-9D2E-4C8C-9998-BD219A3A306C}" dt="2026-01-13T00:05:13.283" v="252" actId="164"/>
-          <ac:spMkLst>
-            <pc:docMk/>
-            <pc:sldMk cId="413350594" sldId="262"/>
-            <ac:spMk id="62" creationId="{123AC3B1-2DDE-5672-C3C4-9127DCF567DD}"/>
-          </ac:spMkLst>
-        </pc:spChg>
-        <pc:spChg chg="mod">
-          <ac:chgData name="Daniel Bauman" userId="b4990c641f0077cd" providerId="LiveId" clId="{6DEDCE68-9D2E-4C8C-9998-BD219A3A306C}" dt="2026-01-21T05:25:14.724" v="254" actId="20577"/>
-          <ac:spMkLst>
-            <pc:docMk/>
-            <pc:sldMk cId="413350594" sldId="262"/>
-            <ac:spMk id="63" creationId="{8C6986AF-6113-54B3-4CFE-3D01F217ABC1}"/>
-          </ac:spMkLst>
-        </pc:spChg>
-        <pc:spChg chg="mod topLvl">
-          <ac:chgData name="Daniel Bauman" userId="b4990c641f0077cd" providerId="LiveId" clId="{6DEDCE68-9D2E-4C8C-9998-BD219A3A306C}" dt="2026-01-13T00:05:13.283" v="252" actId="164"/>
-          <ac:spMkLst>
-            <pc:docMk/>
-            <pc:sldMk cId="413350594" sldId="262"/>
-            <ac:spMk id="64" creationId="{98D85E6D-1DD8-5D9D-36D7-EA818EF4F40C}"/>
-          </ac:spMkLst>
-        </pc:spChg>
-        <pc:grpChg chg="mod">
-          <ac:chgData name="Daniel Bauman" userId="b4990c641f0077cd" providerId="LiveId" clId="{6DEDCE68-9D2E-4C8C-9998-BD219A3A306C}" dt="2026-01-13T00:04:08.640" v="244" actId="14100"/>
-          <ac:grpSpMkLst>
-            <pc:docMk/>
-            <pc:sldMk cId="413350594" sldId="262"/>
-            <ac:grpSpMk id="15" creationId="{48D0738F-1234-8182-A098-5FACEC383D1D}"/>
-          </ac:grpSpMkLst>
-        </pc:grpChg>
-        <pc:grpChg chg="mod">
-          <ac:chgData name="Daniel Bauman" userId="b4990c641f0077cd" providerId="LiveId" clId="{6DEDCE68-9D2E-4C8C-9998-BD219A3A306C}" dt="2026-01-13T00:04:08.640" v="244" actId="14100"/>
-          <ac:grpSpMkLst>
-            <pc:docMk/>
-            <pc:sldMk cId="413350594" sldId="262"/>
-            <ac:grpSpMk id="38" creationId="{DFDB6F18-4F56-4F68-AB8A-9A4ED9404CBD}"/>
-          </ac:grpSpMkLst>
-        </pc:grpChg>
-        <pc:grpChg chg="mod">
-          <ac:chgData name="Daniel Bauman" userId="b4990c641f0077cd" providerId="LiveId" clId="{6DEDCE68-9D2E-4C8C-9998-BD219A3A306C}" dt="2026-01-13T00:04:08.640" v="244" actId="14100"/>
-          <ac:grpSpMkLst>
-            <pc:docMk/>
-            <pc:sldMk cId="413350594" sldId="262"/>
-            <ac:grpSpMk id="39" creationId="{238C3E7C-01FC-4880-800A-16C4C2E98067}"/>
-          </ac:grpSpMkLst>
-        </pc:grpChg>
-        <pc:cxnChg chg="mod">
-          <ac:chgData name="Daniel Bauman" userId="b4990c641f0077cd" providerId="LiveId" clId="{6DEDCE68-9D2E-4C8C-9998-BD219A3A306C}" dt="2026-01-13T00:04:44.562" v="249" actId="14100"/>
-          <ac:cxnSpMkLst>
-            <pc:docMk/>
-            <pc:sldMk cId="413350594" sldId="262"/>
-            <ac:cxnSpMk id="49" creationId="{2E07CD3B-4079-CBE4-6499-340943F12D9A}"/>
-          </ac:cxnSpMkLst>
-        </pc:cxnChg>
-        <pc:cxnChg chg="mod">
-          <ac:chgData name="Daniel Bauman" userId="b4990c641f0077cd" providerId="LiveId" clId="{6DEDCE68-9D2E-4C8C-9998-BD219A3A306C}" dt="2026-01-13T00:04:38.811" v="248" actId="14100"/>
-          <ac:cxnSpMkLst>
-            <pc:docMk/>
-            <pc:sldMk cId="413350594" sldId="262"/>
-            <ac:cxnSpMk id="51" creationId="{0C07CDDA-4A02-10E9-2E28-EC7BDADB6191}"/>
-          </ac:cxnSpMkLst>
-        </pc:cxnChg>
-        <pc:cxnChg chg="mod">
-          <ac:chgData name="Daniel Bauman" userId="b4990c641f0077cd" providerId="LiveId" clId="{6DEDCE68-9D2E-4C8C-9998-BD219A3A306C}" dt="2026-01-13T00:04:33.464" v="247" actId="14100"/>
-          <ac:cxnSpMkLst>
-            <pc:docMk/>
-            <pc:sldMk cId="413350594" sldId="262"/>
-            <ac:cxnSpMk id="52" creationId="{82F091DA-840D-BB81-F02A-444C5502C952}"/>
-          </ac:cxnSpMkLst>
-        </pc:cxnChg>
+            <pc:sldMk cId="3365830087" sldId="263"/>
+            <ac:picMk id="9" creationId="{1D90D720-C212-4F03-3A81-C8779D2BB1C8}"/>
+          </ac:picMkLst>
+        </pc:picChg>
       </pc:sldChg>
     </pc:docChg>
   </pc:docChgLst>
@@ -1338,7 +302,7 @@
           <a:p>
             <a:fld id="{3C4E944E-439C-4400-9867-B448A42A17A7}" type="datetimeFigureOut">
               <a:rPr lang="en-US" smtClean="0"/>
-              <a:t>1/24/2026</a:t>
+              <a:t>3/2/2026</a:t>
             </a:fld>
             <a:endParaRPr lang="en-US"/>
           </a:p>
@@ -1508,7 +472,7 @@
           <a:p>
             <a:fld id="{3C4E944E-439C-4400-9867-B448A42A17A7}" type="datetimeFigureOut">
               <a:rPr lang="en-US" smtClean="0"/>
-              <a:t>1/24/2026</a:t>
+              <a:t>3/2/2026</a:t>
             </a:fld>
             <a:endParaRPr lang="en-US"/>
           </a:p>
@@ -1688,7 +652,7 @@
           <a:p>
             <a:fld id="{3C4E944E-439C-4400-9867-B448A42A17A7}" type="datetimeFigureOut">
               <a:rPr lang="en-US" smtClean="0"/>
-              <a:t>1/24/2026</a:t>
+              <a:t>3/2/2026</a:t>
             </a:fld>
             <a:endParaRPr lang="en-US"/>
           </a:p>
@@ -1858,7 +822,7 @@
           <a:p>
             <a:fld id="{3C4E944E-439C-4400-9867-B448A42A17A7}" type="datetimeFigureOut">
               <a:rPr lang="en-US" smtClean="0"/>
-              <a:t>1/24/2026</a:t>
+              <a:t>3/2/2026</a:t>
             </a:fld>
             <a:endParaRPr lang="en-US"/>
           </a:p>
@@ -2104,7 +1068,7 @@
           <a:p>
             <a:fld id="{3C4E944E-439C-4400-9867-B448A42A17A7}" type="datetimeFigureOut">
               <a:rPr lang="en-US" smtClean="0"/>
-              <a:t>1/24/2026</a:t>
+              <a:t>3/2/2026</a:t>
             </a:fld>
             <a:endParaRPr lang="en-US"/>
           </a:p>
@@ -2336,7 +1300,7 @@
           <a:p>
             <a:fld id="{3C4E944E-439C-4400-9867-B448A42A17A7}" type="datetimeFigureOut">
               <a:rPr lang="en-US" smtClean="0"/>
-              <a:t>1/24/2026</a:t>
+              <a:t>3/2/2026</a:t>
             </a:fld>
             <a:endParaRPr lang="en-US"/>
           </a:p>
@@ -2703,7 +1667,7 @@
           <a:p>
             <a:fld id="{3C4E944E-439C-4400-9867-B448A42A17A7}" type="datetimeFigureOut">
               <a:rPr lang="en-US" smtClean="0"/>
-              <a:t>1/24/2026</a:t>
+              <a:t>3/2/2026</a:t>
             </a:fld>
             <a:endParaRPr lang="en-US"/>
           </a:p>
@@ -2821,7 +1785,7 @@
           <a:p>
             <a:fld id="{3C4E944E-439C-4400-9867-B448A42A17A7}" type="datetimeFigureOut">
               <a:rPr lang="en-US" smtClean="0"/>
-              <a:t>1/24/2026</a:t>
+              <a:t>3/2/2026</a:t>
             </a:fld>
             <a:endParaRPr lang="en-US"/>
           </a:p>
@@ -2916,7 +1880,7 @@
           <a:p>
             <a:fld id="{3C4E944E-439C-4400-9867-B448A42A17A7}" type="datetimeFigureOut">
               <a:rPr lang="en-US" smtClean="0"/>
-              <a:t>1/24/2026</a:t>
+              <a:t>3/2/2026</a:t>
             </a:fld>
             <a:endParaRPr lang="en-US"/>
           </a:p>
@@ -3193,7 +2157,7 @@
           <a:p>
             <a:fld id="{3C4E944E-439C-4400-9867-B448A42A17A7}" type="datetimeFigureOut">
               <a:rPr lang="en-US" smtClean="0"/>
-              <a:t>1/24/2026</a:t>
+              <a:t>3/2/2026</a:t>
             </a:fld>
             <a:endParaRPr lang="en-US"/>
           </a:p>
@@ -3450,7 +2414,7 @@
           <a:p>
             <a:fld id="{3C4E944E-439C-4400-9867-B448A42A17A7}" type="datetimeFigureOut">
               <a:rPr lang="en-US" smtClean="0"/>
-              <a:t>1/24/2026</a:t>
+              <a:t>3/2/2026</a:t>
             </a:fld>
             <a:endParaRPr lang="en-US"/>
           </a:p>
@@ -3663,7 +2627,7 @@
           <a:p>
             <a:fld id="{3C4E944E-439C-4400-9867-B448A42A17A7}" type="datetimeFigureOut">
               <a:rPr lang="en-US" smtClean="0"/>
-              <a:t>1/24/2026</a:t>
+              <a:t>3/2/2026</a:t>
             </a:fld>
             <a:endParaRPr lang="en-US"/>
           </a:p>
@@ -21571,8 +20535,8 @@
             </p:sp>
           </mc:Fallback>
         </mc:AlternateContent>
-        <mc:AlternateContent xmlns:mc="http://schemas.openxmlformats.org/markup-compatibility/2006">
-          <mc:Choice xmlns:a14="http://schemas.microsoft.com/office/drawing/2010/main" Requires="a14">
+        <mc:AlternateContent xmlns:mc="http://schemas.openxmlformats.org/markup-compatibility/2006" xmlns:a14="http://schemas.microsoft.com/office/drawing/2010/main">
+          <mc:Choice Requires="a14">
             <p:sp>
               <p:nvSpPr>
                 <p:cNvPr id="7" name="Rectangle 6">
@@ -21655,7 +20619,7 @@
               </p:txBody>
             </p:sp>
           </mc:Choice>
-          <mc:Fallback>
+          <mc:Fallback xmlns="">
             <p:sp>
               <p:nvSpPr>
                 <p:cNvPr id="7" name="Rectangle 6">
@@ -21705,8 +20669,8 @@
             </p:sp>
           </mc:Fallback>
         </mc:AlternateContent>
-        <mc:AlternateContent xmlns:mc="http://schemas.openxmlformats.org/markup-compatibility/2006">
-          <mc:Choice xmlns:a14="http://schemas.microsoft.com/office/drawing/2010/main" Requires="a14">
+        <mc:AlternateContent xmlns:mc="http://schemas.openxmlformats.org/markup-compatibility/2006" xmlns:a14="http://schemas.microsoft.com/office/drawing/2010/main">
+          <mc:Choice Requires="a14">
             <p:sp>
               <p:nvSpPr>
                 <p:cNvPr id="8" name="Rectangle 7">
@@ -21792,7 +20756,7 @@
               </p:txBody>
             </p:sp>
           </mc:Choice>
-          <mc:Fallback>
+          <mc:Fallback xmlns="">
             <p:sp>
               <p:nvSpPr>
                 <p:cNvPr id="8" name="Rectangle 7">
@@ -22650,8 +21614,8 @@
             </a:fontRef>
           </p:style>
         </p:cxnSp>
-        <mc:AlternateContent xmlns:mc="http://schemas.openxmlformats.org/markup-compatibility/2006">
-          <mc:Choice xmlns:a14="http://schemas.microsoft.com/office/drawing/2010/main" Requires="a14">
+        <mc:AlternateContent xmlns:mc="http://schemas.openxmlformats.org/markup-compatibility/2006" xmlns:a14="http://schemas.microsoft.com/office/drawing/2010/main">
+          <mc:Choice Requires="a14">
             <p:sp>
               <p:nvSpPr>
                 <p:cNvPr id="36" name="TextBox 35">
@@ -22743,7 +21707,7 @@
               </p:txBody>
             </p:sp>
           </mc:Choice>
-          <mc:Fallback>
+          <mc:Fallback xmlns="">
             <p:sp>
               <p:nvSpPr>
                 <p:cNvPr id="36" name="TextBox 35">
@@ -22788,8 +21752,8 @@
             </p:sp>
           </mc:Fallback>
         </mc:AlternateContent>
-        <mc:AlternateContent xmlns:mc="http://schemas.openxmlformats.org/markup-compatibility/2006">
-          <mc:Choice xmlns:a14="http://schemas.microsoft.com/office/drawing/2010/main" Requires="a14">
+        <mc:AlternateContent xmlns:mc="http://schemas.openxmlformats.org/markup-compatibility/2006" xmlns:a14="http://schemas.microsoft.com/office/drawing/2010/main">
+          <mc:Choice Requires="a14">
             <p:sp>
               <p:nvSpPr>
                 <p:cNvPr id="39" name="TextBox 38">
@@ -22851,7 +21815,7 @@
               </p:txBody>
             </p:sp>
           </mc:Choice>
-          <mc:Fallback>
+          <mc:Fallback xmlns="">
             <p:sp>
               <p:nvSpPr>
                 <p:cNvPr id="39" name="TextBox 38">
@@ -22896,8 +21860,8 @@
             </p:sp>
           </mc:Fallback>
         </mc:AlternateContent>
-        <mc:AlternateContent xmlns:mc="http://schemas.openxmlformats.org/markup-compatibility/2006">
-          <mc:Choice xmlns:a14="http://schemas.microsoft.com/office/drawing/2010/main" Requires="a14">
+        <mc:AlternateContent xmlns:mc="http://schemas.openxmlformats.org/markup-compatibility/2006" xmlns:a14="http://schemas.microsoft.com/office/drawing/2010/main">
+          <mc:Choice Requires="a14">
             <p:sp>
               <p:nvSpPr>
                 <p:cNvPr id="40" name="TextBox 39">
@@ -22989,7 +21953,7 @@
               </p:txBody>
             </p:sp>
           </mc:Choice>
-          <mc:Fallback>
+          <mc:Fallback xmlns="">
             <p:sp>
               <p:nvSpPr>
                 <p:cNvPr id="40" name="TextBox 39">
@@ -23142,8 +22106,8 @@
             </p:sp>
           </mc:Fallback>
         </mc:AlternateContent>
-        <mc:AlternateContent xmlns:mc="http://schemas.openxmlformats.org/markup-compatibility/2006">
-          <mc:Choice xmlns:a14="http://schemas.microsoft.com/office/drawing/2010/main" Requires="a14">
+        <mc:AlternateContent xmlns:mc="http://schemas.openxmlformats.org/markup-compatibility/2006" xmlns:a14="http://schemas.microsoft.com/office/drawing/2010/main">
+          <mc:Choice Requires="a14">
             <p:sp>
               <p:nvSpPr>
                 <p:cNvPr id="72" name="TextBox 71">
@@ -23211,7 +22175,7 @@
               </p:txBody>
             </p:sp>
           </mc:Choice>
-          <mc:Fallback>
+          <mc:Fallback xmlns="">
             <p:sp>
               <p:nvSpPr>
                 <p:cNvPr id="72" name="TextBox 71">
@@ -24040,6 +23004,36 @@
 </p:sld>
 </file>
 
+<file path=ppt/slides/slide7.xml><?xml version="1.0" encoding="utf-8"?>
+<p:sld xmlns:a="http://schemas.openxmlformats.org/drawingml/2006/main" xmlns:r="http://schemas.openxmlformats.org/officeDocument/2006/relationships" xmlns:p="http://schemas.openxmlformats.org/presentationml/2006/main">
+  <p:cSld>
+    <p:spTree>
+      <p:nvGrpSpPr>
+        <p:cNvPr id="1" name=""/>
+        <p:cNvGrpSpPr/>
+        <p:nvPr/>
+      </p:nvGrpSpPr>
+      <p:grpSpPr>
+        <a:xfrm>
+          <a:off x="0" y="0"/>
+          <a:ext cx="0" cy="0"/>
+          <a:chOff x="0" y="0"/>
+          <a:chExt cx="0" cy="0"/>
+        </a:xfrm>
+      </p:grpSpPr>
+    </p:spTree>
+    <p:extLst>
+      <p:ext uri="{BB962C8B-B14F-4D97-AF65-F5344CB8AC3E}">
+        <p14:creationId xmlns:p14="http://schemas.microsoft.com/office/powerpoint/2010/main" val="3365830087"/>
+      </p:ext>
+    </p:extLst>
+  </p:cSld>
+  <p:clrMapOvr>
+    <a:masterClrMapping/>
+  </p:clrMapOvr>
+</p:sld>
+</file>
+
 <file path=ppt/theme/theme1.xml><?xml version="1.0" encoding="utf-8"?>
 <a:theme xmlns:a="http://schemas.openxmlformats.org/drawingml/2006/main" name="Office Theme">
   <a:themeElements>

</xml_diff>